<commit_message>
update ppt phase 1
</commit_message>
<xml_diff>
--- a/docs/ppt/ACTIS-Phase-1.pptx
+++ b/docs/ppt/ACTIS-Phase-1.pptx
@@ -6483,8 +6483,8 @@
         </p:nvSpPr>
         <p:spPr bwMode="auto">
           <a:xfrm>
-            <a:off x="2451913" y="-24270"/>
-            <a:ext cx="4587301" cy="2246769"/>
+            <a:off x="1528488" y="324981"/>
+            <a:ext cx="6087022" cy="2739211"/>
           </a:xfrm>
           <a:prstGeom prst="rect">
             <a:avLst/>
@@ -6652,10 +6652,20 @@
               <a:rPr lang="en-US" altLang="en-US" sz="2000" dirty="0">
                 <a:cs typeface="Times New Roman" panose="02020603050405020304" pitchFamily="18" charset="0"/>
               </a:rPr>
-              <a:t>Major Project Review -I : </a:t>
+              <a:t>Major Project Review -I :</a:t>
             </a:r>
+          </a:p>
+          <a:p>
+            <a:pPr algn="ctr">
+              <a:spcBef>
+                <a:spcPct val="0"/>
+              </a:spcBef>
+              <a:buFontTx/>
+              <a:buNone/>
+              <a:defRPr/>
+            </a:pPr>
             <a:r>
-              <a:rPr lang="en-US" sz="2000" b="1" dirty="0" smtClean="0">
+              <a:rPr lang="en-US" sz="2000" b="1" dirty="0">
                 <a:solidFill>
                   <a:srgbClr val="FF0000"/>
                 </a:solidFill>
@@ -6663,8 +6673,18 @@
                 <a:latin typeface="Times New Roman" panose="02020603050405020304" pitchFamily="18" charset="0"/>
                 <a:ea typeface="Times New Roman" panose="02020603050405020304" pitchFamily="18" charset="0"/>
               </a:rPr>
-              <a:t>MCE442P/MCN442P</a:t>
+              <a:t>MCE442P</a:t>
             </a:r>
+          </a:p>
+          <a:p>
+            <a:pPr algn="ctr">
+              <a:spcBef>
+                <a:spcPct val="0"/>
+              </a:spcBef>
+              <a:buFontTx/>
+              <a:buNone/>
+              <a:defRPr/>
+            </a:pPr>
             <a:endParaRPr lang="en-US" altLang="en-US" sz="2000" dirty="0">
               <a:cs typeface="Times New Roman" panose="02020603050405020304" pitchFamily="18" charset="0"/>
             </a:endParaRPr>
@@ -6679,34 +6699,12 @@
               <a:defRPr/>
             </a:pPr>
             <a:r>
-              <a:rPr lang="en-US" altLang="en-US" sz="2000" kern="0" dirty="0">
+              <a:rPr lang="en-US" altLang="en-US" sz="2400" kern="0" dirty="0">
                 <a:cs typeface="Times New Roman" panose="02020603050405020304" pitchFamily="18" charset="0"/>
               </a:rPr>
-              <a:t>Title of the </a:t>
+              <a:t>ACTIS -Agentic Collaborative Threat Intelligence System via Trust-Aware Federated Learning</a:t>
             </a:r>
-            <a:r>
-              <a:rPr lang="en-US" altLang="en-US" sz="2000" kern="0" dirty="0" smtClean="0">
-                <a:cs typeface="Times New Roman" panose="02020603050405020304" pitchFamily="18" charset="0"/>
-              </a:rPr>
-              <a:t>Major </a:t>
-            </a:r>
-            <a:r>
-              <a:rPr lang="en-US" altLang="en-US" sz="2000" kern="0" dirty="0">
-                <a:cs typeface="Times New Roman" panose="02020603050405020304" pitchFamily="18" charset="0"/>
-              </a:rPr>
-              <a:t>Project</a:t>
-            </a:r>
-          </a:p>
-          <a:p>
-            <a:pPr algn="ctr">
-              <a:spcBef>
-                <a:spcPct val="0"/>
-              </a:spcBef>
-              <a:buFontTx/>
-              <a:buNone/>
-              <a:defRPr/>
-            </a:pPr>
-            <a:endParaRPr lang="en-US" altLang="en-US" sz="4000" dirty="0">
+            <a:endParaRPr lang="en-US" altLang="en-US" sz="4400" dirty="0">
               <a:latin typeface="Cambria" panose="02040503050406030204" pitchFamily="18" charset="0"/>
               <a:cs typeface="Arial" panose="020B0604020202020204" pitchFamily="34" charset="0"/>
             </a:endParaRPr>
@@ -6746,8 +6744,8 @@
         </p:nvSpPr>
         <p:spPr bwMode="auto">
           <a:xfrm>
-            <a:off x="850605" y="945226"/>
-            <a:ext cx="7759081" cy="4055717"/>
+            <a:off x="692458" y="2493031"/>
+            <a:ext cx="7759081" cy="2295106"/>
           </a:xfrm>
           <a:prstGeom prst="rect">
             <a:avLst/>
@@ -6934,11 +6932,11 @@
               <a:defRPr/>
             </a:pPr>
             <a:r>
-              <a:rPr lang="en-US" altLang="en-US" sz="2183" dirty="0">
+              <a:rPr lang="en-US" altLang="en-US" sz="2200" dirty="0">
                 <a:latin typeface="Times New Roman" panose="02020603050405020304" pitchFamily="18" charset="0"/>
                 <a:cs typeface="Times New Roman" panose="02020603050405020304" pitchFamily="18" charset="0"/>
               </a:rPr>
-              <a:t>&lt;Student Name&gt;</a:t>
+              <a:t>Veerasagar S S</a:t>
             </a:r>
           </a:p>
           <a:p>
@@ -6946,39 +6944,18 @@
               <a:defRPr/>
             </a:pPr>
             <a:r>
-              <a:rPr lang="en-US" altLang="en-US" sz="2183" dirty="0">
+              <a:rPr lang="en-US" altLang="en-US" sz="2200" dirty="0">
                 <a:latin typeface="Times New Roman" panose="02020603050405020304" pitchFamily="18" charset="0"/>
                 <a:cs typeface="Times New Roman" panose="02020603050405020304" pitchFamily="18" charset="0"/>
               </a:rPr>
-              <a:t>&lt;USN&gt;</a:t>
+              <a:t>1RV24SCS17</a:t>
             </a:r>
           </a:p>
           <a:p>
-            <a:pPr algn="ctr">
+            <a:pPr>
               <a:defRPr/>
             </a:pPr>
-            <a:r>
-              <a:rPr lang="en-US" altLang="en-US" sz="2183" dirty="0">
-                <a:latin typeface="Times New Roman" panose="02020603050405020304" pitchFamily="18" charset="0"/>
-                <a:cs typeface="Times New Roman" panose="02020603050405020304" pitchFamily="18" charset="0"/>
-              </a:rPr>
-              <a:t>&lt;Company Name&gt;</a:t>
-            </a:r>
-          </a:p>
-          <a:p>
-            <a:pPr algn="ctr">
-              <a:defRPr/>
-            </a:pPr>
-            <a:endParaRPr lang="en-US" altLang="en-US" sz="2183" dirty="0">
-              <a:latin typeface="Times New Roman" panose="02020603050405020304" pitchFamily="18" charset="0"/>
-              <a:cs typeface="Times New Roman" panose="02020603050405020304" pitchFamily="18" charset="0"/>
-            </a:endParaRPr>
-          </a:p>
-          <a:p>
-            <a:pPr>
-              <a:defRPr/>
-            </a:pPr>
-            <a:endParaRPr lang="en-US" altLang="en-US" sz="2183" dirty="0">
+            <a:endParaRPr lang="en-US" altLang="en-US" sz="2000" dirty="0">
               <a:latin typeface="Times New Roman" panose="02020603050405020304" pitchFamily="18" charset="0"/>
               <a:cs typeface="Times New Roman" panose="02020603050405020304" pitchFamily="18" charset="0"/>
             </a:endParaRPr>
@@ -6988,15 +6965,11 @@
               <a:defRPr/>
             </a:pPr>
             <a:r>
-              <a:rPr lang="en-US" altLang="en-US" sz="2400" kern="0" dirty="0">
+              <a:rPr lang="en-US" altLang="en-US" sz="2000" kern="0" dirty="0">
                 <a:latin typeface="Times New Roman" panose="02020603050405020304" pitchFamily="18" charset="0"/>
                 <a:cs typeface="Times New Roman" panose="02020603050405020304" pitchFamily="18" charset="0"/>
               </a:rPr>
-              <a:t>    Internal Guide Name             </a:t>
-            </a:r>
-            <a:r>
-              <a:rPr lang="en-US" altLang="en-US" sz="2400" kern="0" dirty="0"/>
-              <a:t>External Guide Name            </a:t>
+              <a:t>    Dr. Rajashree Shettar</a:t>
             </a:r>
           </a:p>
           <a:p>
@@ -7004,72 +6977,28 @@
               <a:defRPr/>
             </a:pPr>
             <a:r>
-              <a:rPr lang="en-US" altLang="en-US" sz="2400" dirty="0">
+              <a:rPr lang="en-US" altLang="en-US" sz="2000" dirty="0">
                 <a:latin typeface="Times New Roman" panose="02020603050405020304" pitchFamily="18" charset="0"/>
                 <a:cs typeface="Times New Roman" panose="02020603050405020304" pitchFamily="18" charset="0"/>
               </a:rPr>
-              <a:t>         </a:t>
+              <a:t>Professor</a:t>
             </a:r>
+            <a:endParaRPr lang="en-US" altLang="en-US" sz="2000" kern="0" dirty="0">
+              <a:latin typeface="Times New Roman" panose="02020603050405020304" pitchFamily="18" charset="0"/>
+              <a:cs typeface="Times New Roman" panose="02020603050405020304" pitchFamily="18" charset="0"/>
+            </a:endParaRPr>
+          </a:p>
+          <a:p>
+            <a:pPr algn="ctr">
+              <a:defRPr/>
+            </a:pPr>
             <a:r>
-              <a:rPr lang="en-US" altLang="en-US" sz="2400" kern="0" dirty="0">
+              <a:rPr lang="en-US" altLang="en-US" sz="2000" dirty="0">
                 <a:latin typeface="Times New Roman" panose="02020603050405020304" pitchFamily="18" charset="0"/>
                 <a:cs typeface="Times New Roman" panose="02020603050405020304" pitchFamily="18" charset="0"/>
               </a:rPr>
-              <a:t>Designation                             </a:t>
+              <a:t>Dept. of CSE, RVCE</a:t>
             </a:r>
-            <a:r>
-              <a:rPr lang="en-US" altLang="en-US" sz="2400" kern="0" dirty="0" err="1">
-                <a:latin typeface="Times New Roman" panose="02020603050405020304" pitchFamily="18" charset="0"/>
-                <a:cs typeface="Times New Roman" panose="02020603050405020304" pitchFamily="18" charset="0"/>
-              </a:rPr>
-              <a:t>Designation</a:t>
-            </a:r>
-            <a:r>
-              <a:rPr lang="en-US" altLang="en-US" sz="2400" kern="0" dirty="0">
-                <a:latin typeface="Times New Roman" panose="02020603050405020304" pitchFamily="18" charset="0"/>
-                <a:cs typeface="Times New Roman" panose="02020603050405020304" pitchFamily="18" charset="0"/>
-              </a:rPr>
-              <a:t> 		               </a:t>
-            </a:r>
-          </a:p>
-          <a:p>
-            <a:pPr algn="ctr">
-              <a:defRPr/>
-            </a:pPr>
-            <a:r>
-              <a:rPr lang="en-US" altLang="en-US" sz="2400" dirty="0">
-                <a:latin typeface="Times New Roman" panose="02020603050405020304" pitchFamily="18" charset="0"/>
-                <a:cs typeface="Times New Roman" panose="02020603050405020304" pitchFamily="18" charset="0"/>
-              </a:rPr>
-              <a:t>         </a:t>
-            </a:r>
-            <a:r>
-              <a:rPr lang="en-US" altLang="en-US" sz="2400" kern="0" dirty="0">
-                <a:latin typeface="Times New Roman" panose="02020603050405020304" pitchFamily="18" charset="0"/>
-                <a:cs typeface="Times New Roman" panose="02020603050405020304" pitchFamily="18" charset="0"/>
-              </a:rPr>
-              <a:t>Organization                           </a:t>
-            </a:r>
-            <a:r>
-              <a:rPr lang="en-US" altLang="en-US" sz="2400" kern="0" dirty="0" err="1">
-                <a:latin typeface="Times New Roman" panose="02020603050405020304" pitchFamily="18" charset="0"/>
-                <a:cs typeface="Times New Roman" panose="02020603050405020304" pitchFamily="18" charset="0"/>
-              </a:rPr>
-              <a:t>Organization</a:t>
-            </a:r>
-            <a:r>
-              <a:rPr lang="en-US" altLang="en-US" sz="2400" kern="0" dirty="0">
-                <a:latin typeface="Times New Roman" panose="02020603050405020304" pitchFamily="18" charset="0"/>
-                <a:cs typeface="Times New Roman" panose="02020603050405020304" pitchFamily="18" charset="0"/>
-              </a:rPr>
-              <a:t> 								</a:t>
-            </a:r>
-          </a:p>
-          <a:p>
-            <a:pPr>
-              <a:defRPr/>
-            </a:pPr>
-            <a:endParaRPr lang="en-US" altLang="en-US" sz="2183" dirty="0"/>
           </a:p>
         </p:txBody>
       </p:sp>
@@ -7141,14 +7070,6 @@
                 </a:solidFill>
               </a:rPr>
               <a:t>Synopsis (Word copy)</a:t>
-            </a:r>
-            <a:r>
-              <a:rPr lang="en-US" altLang="en-US" sz="2800" dirty="0">
-                <a:solidFill>
-                  <a:schemeClr val="tx2"/>
-                </a:solidFill>
-              </a:rPr>
-              <a:t/>
             </a:r>
             <a:br>
               <a:rPr lang="en-US" altLang="en-US" sz="2800" dirty="0">
@@ -8152,7 +8073,7 @@
         <p:spPr bwMode="auto">
           <a:xfrm>
             <a:off x="451835" y="947287"/>
-            <a:ext cx="7645705" cy="3951723"/>
+            <a:ext cx="7645705" cy="3028393"/>
           </a:xfrm>
           <a:prstGeom prst="rect">
             <a:avLst/>
@@ -8343,7 +8264,7 @@
               <a:buChar char="•"/>
             </a:pPr>
             <a:r>
-              <a:rPr lang="en-US" altLang="en-US" sz="3200" dirty="0"/>
+              <a:rPr lang="en-US" altLang="en-US" sz="2800" dirty="0"/>
               <a:t>Introduction about the project</a:t>
             </a:r>
           </a:p>
@@ -8356,12 +8277,8 @@
               <a:buChar char="•"/>
             </a:pPr>
             <a:r>
-              <a:rPr lang="en-US" sz="3200" dirty="0"/>
-              <a:t>Relevance of Topic and Problem </a:t>
-            </a:r>
-            <a:r>
-              <a:rPr lang="en-US" sz="3200" dirty="0" smtClean="0"/>
-              <a:t>Identification</a:t>
+              <a:rPr lang="en-US" sz="2800" dirty="0"/>
+              <a:t>Relevance of Topic and Problem Identification</a:t>
             </a:r>
           </a:p>
           <a:p>
@@ -8373,7 +8290,7 @@
               <a:buChar char="•"/>
             </a:pPr>
             <a:r>
-              <a:rPr lang="en-US" altLang="en-US" sz="3200" dirty="0"/>
+              <a:rPr lang="en-US" altLang="en-US" sz="2800" dirty="0"/>
               <a:t>Project Objectives</a:t>
             </a:r>
           </a:p>
@@ -8386,18 +8303,9 @@
               <a:buChar char="•"/>
             </a:pPr>
             <a:r>
-              <a:rPr lang="en-US" altLang="en-US" sz="3200" dirty="0"/>
-              <a:t>Project </a:t>
+              <a:rPr lang="en-US" altLang="en-US" sz="2800" dirty="0"/>
+              <a:t>Project Scope </a:t>
             </a:r>
-            <a:r>
-              <a:rPr lang="en-US" altLang="en-US" sz="3200" dirty="0" smtClean="0"/>
-              <a:t>Scope</a:t>
-            </a:r>
-            <a:r>
-              <a:rPr lang="en-US" altLang="en-US" sz="3200" dirty="0" smtClean="0"/>
-              <a:t> </a:t>
-            </a:r>
-            <a:endParaRPr lang="en-US" altLang="en-US" sz="3200" dirty="0"/>
           </a:p>
           <a:p>
             <a:pPr>
@@ -8408,12 +8316,8 @@
               <a:buChar char="•"/>
             </a:pPr>
             <a:r>
-              <a:rPr lang="en-US" sz="3200" dirty="0"/>
-              <a:t>Literature </a:t>
-            </a:r>
-            <a:r>
-              <a:rPr lang="en-US" sz="3200" dirty="0" smtClean="0"/>
-              <a:t>Survey</a:t>
+              <a:rPr lang="en-US" sz="2800" dirty="0"/>
+              <a:t>Literature Survey</a:t>
             </a:r>
           </a:p>
           <a:p>
@@ -8425,7 +8329,7 @@
               <a:buChar char="•"/>
             </a:pPr>
             <a:r>
-              <a:rPr lang="en-US" altLang="en-US" sz="3200" dirty="0" smtClean="0"/>
+              <a:rPr lang="en-US" altLang="en-US" sz="2800" dirty="0"/>
               <a:t>Synopsis</a:t>
             </a:r>
           </a:p>
@@ -8438,10 +8342,10 @@
               <a:buChar char="•"/>
             </a:pPr>
             <a:r>
-              <a:rPr lang="en-US" altLang="en-US" sz="3200" dirty="0" smtClean="0"/>
+              <a:rPr lang="en-US" altLang="en-US" sz="2800" dirty="0"/>
               <a:t>References</a:t>
             </a:r>
-            <a:endParaRPr lang="en-US" altLang="en-US" sz="3200" dirty="0">
+            <a:endParaRPr lang="en-US" altLang="en-US" sz="2800" dirty="0">
               <a:latin typeface="Times New Roman" panose="02020603050405020304" pitchFamily="18" charset="0"/>
               <a:cs typeface="Times New Roman" panose="02020603050405020304" pitchFamily="18" charset="0"/>
             </a:endParaRPr>
@@ -8890,6 +8794,122 @@
           </a:p>
         </p:txBody>
       </p:sp>
+      <p:sp>
+        <p:nvSpPr>
+          <p:cNvPr id="5" name="TextBox 4">
+            <a:extLst>
+              <a:ext uri="{FF2B5EF4-FFF2-40B4-BE49-F238E27FC236}">
+                <a16:creationId xmlns:a16="http://schemas.microsoft.com/office/drawing/2014/main" id="{B4042DDB-D2C7-C416-A797-BB2A0AA68F7D}"/>
+              </a:ext>
+            </a:extLst>
+          </p:cNvPr>
+          <p:cNvSpPr txBox="1"/>
+          <p:nvPr/>
+        </p:nvSpPr>
+        <p:spPr>
+          <a:xfrm>
+            <a:off x="790303" y="1280160"/>
+            <a:ext cx="184731" cy="307777"/>
+          </a:xfrm>
+          <a:prstGeom prst="rect">
+            <a:avLst/>
+          </a:prstGeom>
+          <a:noFill/>
+        </p:spPr>
+        <p:txBody>
+          <a:bodyPr wrap="none" rtlCol="0">
+            <a:spAutoFit/>
+          </a:bodyPr>
+          <a:lstStyle/>
+          <a:p>
+            <a:endParaRPr lang="en-US" dirty="0"/>
+          </a:p>
+        </p:txBody>
+      </p:sp>
+      <p:sp>
+        <p:nvSpPr>
+          <p:cNvPr id="6" name="TextBox 5">
+            <a:extLst>
+              <a:ext uri="{FF2B5EF4-FFF2-40B4-BE49-F238E27FC236}">
+                <a16:creationId xmlns:a16="http://schemas.microsoft.com/office/drawing/2014/main" id="{E9AFFB70-96FD-BDB7-F909-51AE5A412E77}"/>
+              </a:ext>
+            </a:extLst>
+          </p:cNvPr>
+          <p:cNvSpPr txBox="1"/>
+          <p:nvPr/>
+        </p:nvSpPr>
+        <p:spPr>
+          <a:xfrm>
+            <a:off x="385354" y="999309"/>
+            <a:ext cx="8314509" cy="3108543"/>
+          </a:xfrm>
+          <a:prstGeom prst="rect">
+            <a:avLst/>
+          </a:prstGeom>
+          <a:noFill/>
+        </p:spPr>
+        <p:txBody>
+          <a:bodyPr wrap="square" rtlCol="0">
+            <a:spAutoFit/>
+          </a:bodyPr>
+          <a:lstStyle/>
+          <a:p>
+            <a:pPr marL="285750" indent="-285750">
+              <a:buFont typeface="Arial" panose="020B0604020202020204" pitchFamily="34" charset="0"/>
+              <a:buChar char="•"/>
+            </a:pPr>
+            <a:r>
+              <a:rPr lang="en-US" dirty="0"/>
+              <a:t>Modern enterprise networks are facing an unprecedented volume of sophisticated, fast-moving cyber attacks. Threat actors are increasingly utilizing automated tools and AI to generate novel "zero-day" exploits that bypass traditional, signature-based defenses.</a:t>
+            </a:r>
+          </a:p>
+          <a:p>
+            <a:pPr marL="285750" indent="-285750">
+              <a:buFont typeface="Arial" panose="020B0604020202020204" pitchFamily="34" charset="0"/>
+              <a:buChar char="•"/>
+            </a:pPr>
+            <a:r>
+              <a:rPr lang="en-US" dirty="0"/>
+              <a:t>Currently, organizations operate in silos. When a zero-day attack breaches Company A, Company B remains entirely unaware and vulnerable until security vendors manually analyze the breach and distribute a patch. This "human-in-the-loop" latency is the exact window where attacks propagate globally.</a:t>
+            </a:r>
+          </a:p>
+          <a:p>
+            <a:pPr marL="285750" indent="-285750">
+              <a:buFont typeface="Arial" panose="020B0604020202020204" pitchFamily="34" charset="0"/>
+              <a:buChar char="•"/>
+            </a:pPr>
+            <a:r>
+              <a:rPr lang="en-US" dirty="0"/>
+              <a:t>The logical solution is for organizations to pool their network traffic logs to train a massive, collective AI defense system. However, strict data privacy laws (like GDPR and CCPA) and the risk of leaking internal IP addresses, user credentials, or proprietary network structures (Personally Identifiable Information - PII) make sharing raw telemetry legally and operationally impossible. </a:t>
+            </a:r>
+          </a:p>
+          <a:p>
+            <a:pPr marL="285750" indent="-285750">
+              <a:buFont typeface="Arial" panose="020B0604020202020204" pitchFamily="34" charset="0"/>
+              <a:buChar char="•"/>
+            </a:pPr>
+            <a:r>
+              <a:rPr lang="en-US" dirty="0"/>
+              <a:t>This project introduces </a:t>
+            </a:r>
+            <a:r>
+              <a:rPr lang="en-US" b="1" dirty="0"/>
+              <a:t>ACTIS (Agentic Collaborative Threat Intelligence System)</a:t>
+            </a:r>
+            <a:r>
+              <a:rPr lang="en-US" dirty="0"/>
+              <a:t>, a comprehensive AI-driven framework designed to solve the collaboration-privacy paradox.</a:t>
+            </a:r>
+          </a:p>
+          <a:p>
+            <a:pPr marL="285750" indent="-285750">
+              <a:buFont typeface="Arial" panose="020B0604020202020204" pitchFamily="34" charset="0"/>
+              <a:buChar char="•"/>
+            </a:pPr>
+            <a:endParaRPr lang="en-US" dirty="0"/>
+          </a:p>
+        </p:txBody>
+      </p:sp>
     </p:spTree>
   </p:cSld>
   <p:clrMapOvr>
@@ -8931,7 +8951,7 @@
         </p:nvSpPr>
         <p:spPr bwMode="auto">
           <a:xfrm>
-            <a:off x="2519429" y="117057"/>
+            <a:off x="2519429" y="162777"/>
             <a:ext cx="4105141" cy="319959"/>
           </a:xfrm>
           <a:prstGeom prst="rect">
@@ -9088,7 +9108,7 @@
             </a:lvl9pPr>
           </a:lstStyle>
           <a:p>
-            <a:pPr>
+            <a:pPr algn="ctr">
               <a:spcBef>
                 <a:spcPct val="0"/>
               </a:spcBef>
@@ -9098,19 +9118,8 @@
                 <a:latin typeface="Times New Roman" panose="02020603050405020304" pitchFamily="18" charset="0"/>
                 <a:cs typeface="Times New Roman" panose="02020603050405020304" pitchFamily="18" charset="0"/>
               </a:rPr>
-              <a:t>       </a:t>
-            </a:r>
-            <a:r>
-              <a:rPr lang="en-US" altLang="en-US" sz="2000" dirty="0" smtClean="0">
-                <a:latin typeface="Times New Roman" panose="02020603050405020304" pitchFamily="18" charset="0"/>
-                <a:cs typeface="Times New Roman" panose="02020603050405020304" pitchFamily="18" charset="0"/>
-              </a:rPr>
               <a:t>Relevance of Topic</a:t>
             </a:r>
-            <a:endParaRPr lang="en-US" altLang="en-US" sz="2000" dirty="0">
-              <a:latin typeface="Times New Roman" panose="02020603050405020304" pitchFamily="18" charset="0"/>
-              <a:cs typeface="Times New Roman" panose="02020603050405020304" pitchFamily="18" charset="0"/>
-            </a:endParaRPr>
           </a:p>
         </p:txBody>
       </p:sp>
@@ -9189,21 +9198,8 @@
                   <a:schemeClr val="tx1"/>
                 </a:solidFill>
               </a:rPr>
-              <a:t>Problem </a:t>
+              <a:t>Problem Identification</a:t>
             </a:r>
-            <a:r>
-              <a:rPr lang="en-US" altLang="en-US" sz="2000" dirty="0" smtClean="0">
-                <a:solidFill>
-                  <a:schemeClr val="tx1"/>
-                </a:solidFill>
-              </a:rPr>
-              <a:t>Identification</a:t>
-            </a:r>
-            <a:endParaRPr lang="en-US" altLang="en-US" sz="2000" dirty="0">
-              <a:solidFill>
-                <a:schemeClr val="tx1"/>
-              </a:solidFill>
-            </a:endParaRPr>
           </a:p>
         </p:txBody>
       </p:sp>
@@ -9496,10 +9492,9 @@
               </a:spcBef>
             </a:pPr>
             <a:r>
-              <a:rPr lang="en-US" altLang="en-US" sz="2000" dirty="0" smtClean="0"/>
+              <a:rPr lang="en-US" altLang="en-US" sz="2000" dirty="0"/>
               <a:t>Project Scope</a:t>
             </a:r>
-            <a:endParaRPr lang="en-US" altLang="en-US" sz="2000" dirty="0"/>
           </a:p>
         </p:txBody>
       </p:sp>

</xml_diff>

<commit_message>
Update ACTIS Phase 1 presentation and macOS directory metadata files.
</commit_message>
<xml_diff>
--- a/docs/ppt/ACTIS-Phase-1.pptx
+++ b/docs/ppt/ACTIS-Phase-1.pptx
@@ -7580,7 +7580,7 @@
         <p:spPr bwMode="auto">
           <a:xfrm>
             <a:off x="2223903" y="110829"/>
-            <a:ext cx="4526747" cy="627736"/>
+            <a:ext cx="4526747" cy="319959"/>
           </a:xfrm>
           <a:prstGeom prst="rect">
             <a:avLst/>
@@ -7736,23 +7736,15 @@
             </a:lvl9pPr>
           </a:lstStyle>
           <a:p>
-            <a:pPr>
+            <a:pPr algn="ctr">
               <a:spcBef>
                 <a:spcPct val="0"/>
               </a:spcBef>
             </a:pPr>
             <a:r>
               <a:rPr lang="en-US" altLang="en-US" sz="2000" dirty="0"/>
-              <a:t>     Literature Survey(Minimum 20 papers)</a:t>
+              <a:t>     Literature Survey</a:t>
             </a:r>
-          </a:p>
-          <a:p>
-            <a:pPr>
-              <a:spcBef>
-                <a:spcPct val="0"/>
-              </a:spcBef>
-            </a:pPr>
-            <a:endParaRPr lang="en-US" altLang="en-US" sz="2000" dirty="0"/>
           </a:p>
         </p:txBody>
       </p:sp>
@@ -8452,7 +8444,7 @@
         <p:spPr bwMode="auto">
           <a:xfrm>
             <a:off x="2223903" y="110829"/>
-            <a:ext cx="4526747" cy="627736"/>
+            <a:ext cx="4526747" cy="319959"/>
           </a:xfrm>
           <a:prstGeom prst="rect">
             <a:avLst/>
@@ -8608,23 +8600,15 @@
             </a:lvl9pPr>
           </a:lstStyle>
           <a:p>
-            <a:pPr>
+            <a:pPr algn="ctr">
               <a:spcBef>
                 <a:spcPct val="0"/>
               </a:spcBef>
             </a:pPr>
             <a:r>
               <a:rPr lang="en-US" altLang="en-US" sz="2000" dirty="0"/>
-              <a:t>     Literature Survey(Minimum 20 papers)</a:t>
+              <a:t>     Literature Survey</a:t>
             </a:r>
-          </a:p>
-          <a:p>
-            <a:pPr>
-              <a:spcBef>
-                <a:spcPct val="0"/>
-              </a:spcBef>
-            </a:pPr>
-            <a:endParaRPr lang="en-US" altLang="en-US" sz="2000" dirty="0"/>
           </a:p>
         </p:txBody>
       </p:sp>
@@ -9312,7 +9296,7 @@
         <p:spPr bwMode="auto">
           <a:xfrm>
             <a:off x="2223903" y="110829"/>
-            <a:ext cx="4526747" cy="627736"/>
+            <a:ext cx="4526747" cy="319959"/>
           </a:xfrm>
           <a:prstGeom prst="rect">
             <a:avLst/>
@@ -9468,28 +9452,20 @@
             </a:lvl9pPr>
           </a:lstStyle>
           <a:p>
-            <a:pPr>
+            <a:pPr algn="ctr">
               <a:spcBef>
                 <a:spcPct val="0"/>
               </a:spcBef>
             </a:pPr>
             <a:r>
               <a:rPr lang="en-US" altLang="en-US" sz="2000" dirty="0"/>
-              <a:t>     Literature Survey(Minimum 20 papers)</a:t>
+              <a:t>     Literature Survey</a:t>
             </a:r>
-          </a:p>
-          <a:p>
-            <a:pPr>
-              <a:spcBef>
-                <a:spcPct val="0"/>
-              </a:spcBef>
-            </a:pPr>
-            <a:endParaRPr lang="en-US" altLang="en-US" sz="2000" dirty="0"/>
           </a:p>
         </p:txBody>
       </p:sp>
-      <mc:AlternateContent xmlns:mc="http://schemas.openxmlformats.org/markup-compatibility/2006">
-        <mc:Choice xmlns:a14="http://schemas.microsoft.com/office/drawing/2010/main" Requires="a14">
+      <mc:AlternateContent xmlns:mc="http://schemas.openxmlformats.org/markup-compatibility/2006" xmlns:a14="http://schemas.microsoft.com/office/drawing/2010/main">
+        <mc:Choice Requires="a14">
           <p:graphicFrame>
             <p:nvGraphicFramePr>
               <p:cNvPr id="3" name="Table 2">
@@ -9663,7 +9639,7 @@
                             <a:buNone/>
                           </a:pPr>
                           <a:r>
-                            <a:rPr lang="en-US" sz="1000">
+                            <a:rPr lang="en-US" sz="1000" dirty="0">
                               <a:effectLst/>
                             </a:rPr>
                             <a:t>17</a:t>
@@ -9984,7 +9960,7 @@
                             <a:buNone/>
                           </a:pPr>
                           <a:r>
-                            <a:rPr lang="en-US" sz="1000">
+                            <a:rPr lang="en-US" sz="1000" dirty="0">
                               <a:effectLst/>
                             </a:rPr>
                             <a:t>Applies LDP to neural network gradient updates explicitly during the FL optimization passes.</a:t>
@@ -10138,7 +10114,7 @@
             </a:graphic>
           </p:graphicFrame>
         </mc:Choice>
-        <mc:Fallback>
+        <mc:Fallback xmlns="">
           <p:graphicFrame>
             <p:nvGraphicFramePr>
               <p:cNvPr id="3" name="Table 2">
@@ -11005,7 +10981,7 @@
           </a:bodyPr>
           <a:lstStyle/>
           <a:p>
-            <a:pPr>
+            <a:pPr algn="ctr">
               <a:spcBef>
                 <a:spcPct val="0"/>
               </a:spcBef>
@@ -11016,7 +10992,7 @@
                   <a:schemeClr val="tx1"/>
                 </a:solidFill>
               </a:rPr>
-              <a:t>References(Minimum 10 with all details)</a:t>
+              <a:t>References</a:t>
             </a:r>
           </a:p>
         </p:txBody>
@@ -11292,7 +11268,7 @@
           </a:bodyPr>
           <a:lstStyle/>
           <a:p>
-            <a:pPr>
+            <a:pPr algn="ctr">
               <a:spcBef>
                 <a:spcPct val="0"/>
               </a:spcBef>
@@ -11303,7 +11279,7 @@
                   <a:schemeClr val="tx1"/>
                 </a:solidFill>
               </a:rPr>
-              <a:t>References(Minimum 10 with all details)</a:t>
+              <a:t>References</a:t>
             </a:r>
           </a:p>
         </p:txBody>
@@ -13070,7 +13046,15 @@
             </a:r>
             <a:r>
               <a:rPr lang="en-US" dirty="0"/>
-              <a:t> To design an Agentic Privacy Engine—powered by Large Language Models and Regex validation loops—that autonomously strips 100% of PII from threat reports locally, </a:t>
+              <a:t> To design an Agentic </a:t>
+            </a:r>
+            <a:r>
+              <a:rPr lang="en-US"/>
+              <a:t>Privacy Engine powered </a:t>
+            </a:r>
+            <a:r>
+              <a:rPr lang="en-US" dirty="0"/>
+              <a:t>by Large Language Models and Regex validation loops—that autonomously strips 100% of PII from threat reports locally, </a:t>
             </a:r>
             <a:r>
               <a:rPr lang="en-US" i="1" dirty="0"/>
@@ -13379,8 +13363,12 @@
               <a:buChar char="•"/>
             </a:pPr>
             <a:r>
+              <a:rPr lang="en-US" b="1" dirty="0"/>
+              <a:t>Financial Institutions &amp; Banks</a:t>
+            </a:r>
+            <a:r>
               <a:rPr lang="en-US" dirty="0"/>
-              <a:t>Financial Institutions &amp; Banks: Competing banks can pool their cyber defenses to instantly block new financial exploits (like SWIFT network attacks) without legally violating customer privacy or exposing proprietary ledgers.</a:t>
+              <a:t>: Competing banks can pool their cyber defenses to instantly block new financial exploits (like SWIFT network attacks) without legally violating customer privacy or exposing proprietary ledgers.</a:t>
             </a:r>
           </a:p>
           <a:p>
@@ -13392,8 +13380,12 @@
               <a:buChar char="•"/>
             </a:pPr>
             <a:r>
+              <a:rPr lang="en-US" b="1" dirty="0"/>
+              <a:t>Healthcare Networks</a:t>
+            </a:r>
+            <a:r>
               <a:rPr lang="en-US" dirty="0"/>
-              <a:t>Healthcare Networks: Hospitals can collaborate to stop horizontal ransomware spread without ever transmitting protected patient records (HIPAA compliance), as only mathematical noise and sanitized summaries are shared.</a:t>
+              <a:t>: Hospitals can collaborate to stop horizontal ransomware spread without ever transmitting protected patient records (HIPAA compliance), as only mathematical noise and sanitized summaries are shared.</a:t>
             </a:r>
           </a:p>
           <a:p>
@@ -13405,8 +13397,12 @@
               <a:buChar char="•"/>
             </a:pPr>
             <a:r>
+              <a:rPr lang="en-US" b="1" dirty="0"/>
+              <a:t>Critical Infrastructure (Power Grids &amp; Water Plants)</a:t>
+            </a:r>
+            <a:r>
               <a:rPr lang="en-US" dirty="0"/>
-              <a:t>Critical Infrastructure (Power Grids &amp; Water Plants): Regional SCADA networks can deploy ACTIS to autonomously identify and block state-sponsored malware across the national grid without needing high-bandwidth continuous cloud monitoring.</a:t>
+              <a:t>: Regional SCADA networks can deploy ACTIS to autonomously identify and block state-sponsored malware across the national grid without needing high-bandwidth continuous cloud monitoring.</a:t>
             </a:r>
           </a:p>
           <a:p>
@@ -13418,8 +13414,12 @@
               <a:buChar char="•"/>
             </a:pPr>
             <a:r>
+              <a:rPr lang="en-US" b="1" dirty="0"/>
+              <a:t>Managed Security Service Providers (MSSPs): </a:t>
+            </a:r>
+            <a:r>
               <a:rPr lang="en-US" dirty="0"/>
-              <a:t>Managed Security Service Providers (MSSPs): Cybersecurity companies can deploy ACTIS across hundreds of distinct corporate clients, creating a unified "hive mind" defense instantly protecting Client B when Client A is attacked, without mixing their restricted data.</a:t>
+              <a:t>Cybersecurity companies can deploy ACTIS across hundreds of distinct corporate clients, creating a unified "hive mind" defense instantly protecting Client B when Client A is attacked, without mixing their restricted data.</a:t>
             </a:r>
           </a:p>
         </p:txBody>
@@ -13627,14 +13627,14 @@
             </a:lvl9pPr>
           </a:lstStyle>
           <a:p>
-            <a:pPr>
+            <a:pPr algn="ctr">
               <a:spcBef>
                 <a:spcPct val="0"/>
               </a:spcBef>
             </a:pPr>
             <a:r>
               <a:rPr lang="en-US" altLang="en-US" sz="2000" dirty="0"/>
-              <a:t>     Literature Survey(Minimum 20 papers)</a:t>
+              <a:t>     Literature Survey</a:t>
             </a:r>
           </a:p>
           <a:p>
@@ -14363,7 +14363,7 @@
         <p:spPr bwMode="auto">
           <a:xfrm>
             <a:off x="2223903" y="110829"/>
-            <a:ext cx="4526747" cy="627736"/>
+            <a:ext cx="4526747" cy="319959"/>
           </a:xfrm>
           <a:prstGeom prst="rect">
             <a:avLst/>
@@ -14519,23 +14519,15 @@
             </a:lvl9pPr>
           </a:lstStyle>
           <a:p>
-            <a:pPr>
+            <a:pPr algn="ctr">
               <a:spcBef>
                 <a:spcPct val="0"/>
               </a:spcBef>
             </a:pPr>
             <a:r>
               <a:rPr lang="en-US" altLang="en-US" sz="2000" dirty="0"/>
-              <a:t>     Literature Survey(Minimum 20 papers)</a:t>
+              <a:t>     Literature Survey</a:t>
             </a:r>
-          </a:p>
-          <a:p>
-            <a:pPr>
-              <a:spcBef>
-                <a:spcPct val="0"/>
-              </a:spcBef>
-            </a:pPr>
-            <a:endParaRPr lang="en-US" altLang="en-US" sz="2000" dirty="0"/>
           </a:p>
         </p:txBody>
       </p:sp>

</xml_diff>